<commit_message>
Align submission documents and provenance evidence
</commit_message>
<xml_diff>
--- a/SchedX-Agent_项目介绍.pptx
+++ b/SchedX-Agent_项目介绍.pptx
@@ -1929,7 +1929,7 @@
           <a:lstStyle/>
           <a:p>
             <a:fld id="{DBA00916-396A-A444-B6A6-572F44C7530F}" type="datetimeFigureOut">
-              <a:t>2026/7/29</a:t>
+              <a:t>2026/7/30</a:t>
             </a:fld>
             <a:endParaRPr/>
           </a:p>
@@ -2383,7 +2383,7 @@
           <a:lstStyle/>
           <a:p>
             <a:fld id="{DBA00916-396A-A444-B6A6-572F44C7530F}" type="datetimeFigureOut">
-              <a:t>2026/7/29</a:t>
+              <a:t>2026/7/30</a:t>
             </a:fld>
             <a:endParaRPr/>
           </a:p>
@@ -3328,7 +3328,7 @@
           <a:lstStyle/>
           <a:p>
             <a:fld id="{DBA00916-396A-A444-B6A6-572F44C7530F}" type="datetimeFigureOut">
-              <a:t>2026/7/29</a:t>
+              <a:t>2026/7/30</a:t>
             </a:fld>
             <a:endParaRPr/>
           </a:p>
@@ -4018,7 +4018,7 @@
           <a:lstStyle/>
           <a:p>
             <a:fld id="{DBA00916-396A-A444-B6A6-572F44C7530F}" type="datetimeFigureOut">
-              <a:t>2026/7/29</a:t>
+              <a:t>2026/7/30</a:t>
             </a:fld>
             <a:endParaRPr/>
           </a:p>
@@ -4963,7 +4963,7 @@
           <a:lstStyle/>
           <a:p>
             <a:fld id="{DBA00916-396A-A444-B6A6-572F44C7530F}" type="datetimeFigureOut">
-              <a:t>2026/7/29</a:t>
+              <a:t>2026/7/30</a:t>
             </a:fld>
             <a:endParaRPr/>
           </a:p>
@@ -5676,7 +5676,7 @@
           <a:lstStyle/>
           <a:p>
             <a:fld id="{DBA00916-396A-A444-B6A6-572F44C7530F}" type="datetimeFigureOut">
-              <a:t>2026/7/29</a:t>
+              <a:t>2026/7/30</a:t>
             </a:fld>
             <a:endParaRPr/>
           </a:p>
@@ -5989,7 +5989,7 @@
           <a:lstStyle/>
           <a:p>
             <a:fld id="{DBA00916-396A-A444-B6A6-572F44C7530F}" type="datetimeFigureOut">
-              <a:t>2026/7/29</a:t>
+              <a:t>2026/7/30</a:t>
             </a:fld>
             <a:endParaRPr/>
           </a:p>
@@ -6675,7 +6675,7 @@
           <a:lstStyle/>
           <a:p>
             <a:fld id="{DBA00916-396A-A444-B6A6-572F44C7530F}" type="datetimeFigureOut">
-              <a:t>2026/7/29</a:t>
+              <a:t>2026/7/30</a:t>
             </a:fld>
             <a:endParaRPr/>
           </a:p>
@@ -7216,7 +7216,7 @@
           <a:lstStyle/>
           <a:p>
             <a:fld id="{DBA00916-396A-A444-B6A6-572F44C7530F}" type="datetimeFigureOut">
-              <a:t>2026/7/29</a:t>
+              <a:t>2026/7/30</a:t>
             </a:fld>
             <a:endParaRPr/>
           </a:p>
@@ -7330,7 +7330,7 @@
           <a:lstStyle/>
           <a:p>
             <a:fld id="{DBA00916-396A-A444-B6A6-572F44C7530F}" type="datetimeFigureOut">
-              <a:t>2026/7/29</a:t>
+              <a:t>2026/7/30</a:t>
             </a:fld>
             <a:endParaRPr/>
           </a:p>
@@ -7760,7 +7760,7 @@
           <a:lstStyle/>
           <a:p>
             <a:fld id="{DBA00916-396A-A444-B6A6-572F44C7530F}" type="datetimeFigureOut">
-              <a:t>2026/7/29</a:t>
+              <a:t>2026/7/30</a:t>
             </a:fld>
             <a:endParaRPr/>
           </a:p>
@@ -8027,7 +8027,7 @@
           <a:lstStyle/>
           <a:p>
             <a:fld id="{DBA00916-396A-A444-B6A6-572F44C7530F}" type="datetimeFigureOut">
-              <a:t>2026/7/29</a:t>
+              <a:t>2026/7/30</a:t>
             </a:fld>
             <a:endParaRPr/>
           </a:p>
@@ -8443,7 +8443,7 @@
           <a:lstStyle/>
           <a:p>
             <a:fld id="{DBA00916-396A-A444-B6A6-572F44C7530F}" type="datetimeFigureOut">
-              <a:t>2026/7/29</a:t>
+              <a:t>2026/7/30</a:t>
             </a:fld>
             <a:endParaRPr/>
           </a:p>
@@ -8549,7 +8549,7 @@
           <a:lstStyle/>
           <a:p>
             <a:fld id="{DBA00916-396A-A444-B6A6-572F44C7530F}" type="datetimeFigureOut">
-              <a:t>2026/7/29</a:t>
+              <a:t>2026/7/30</a:t>
             </a:fld>
             <a:endParaRPr/>
           </a:p>
@@ -8868,7 +8868,7 @@
           <a:lstStyle/>
           <a:p>
             <a:fld id="{DBA00916-396A-A444-B6A6-572F44C7530F}" type="datetimeFigureOut">
-              <a:t>2026/7/29</a:t>
+              <a:t>2026/7/30</a:t>
             </a:fld>
             <a:endParaRPr/>
           </a:p>
@@ -9150,7 +9150,7 @@
           <a:lstStyle/>
           <a:p>
             <a:fld id="{DBA00916-396A-A444-B6A6-572F44C7530F}" type="datetimeFigureOut">
-              <a:t>2026/7/29</a:t>
+              <a:t>2026/7/30</a:t>
             </a:fld>
             <a:endParaRPr/>
           </a:p>
@@ -9345,7 +9345,7 @@
           <a:lstStyle/>
           <a:p>
             <a:fld id="{DBA00916-396A-A444-B6A6-572F44C7530F}" type="datetimeFigureOut">
-              <a:t>2026/7/29</a:t>
+              <a:t>2026/7/30</a:t>
             </a:fld>
             <a:endParaRPr/>
           </a:p>
@@ -9550,7 +9550,7 @@
           <a:lstStyle/>
           <a:p>
             <a:fld id="{DBA00916-396A-A444-B6A6-572F44C7530F}" type="datetimeFigureOut">
-              <a:t>2026/7/29</a:t>
+              <a:t>2026/7/30</a:t>
             </a:fld>
             <a:endParaRPr/>
           </a:p>
@@ -9687,7 +9687,7 @@
           <a:lstStyle/>
           <a:p>
             <a:fld id="{DBA00916-396A-A444-B6A6-572F44C7530F}" type="datetimeFigureOut">
-              <a:t>2026/7/29</a:t>
+              <a:t>2026/7/30</a:t>
             </a:fld>
             <a:endParaRPr/>
           </a:p>
@@ -10000,7 +10000,7 @@
           <a:lstStyle/>
           <a:p>
             <a:fld id="{DBA00916-396A-A444-B6A6-572F44C7530F}" type="datetimeFigureOut">
-              <a:t>2026/7/29</a:t>
+              <a:t>2026/7/30</a:t>
             </a:fld>
             <a:endParaRPr/>
           </a:p>
@@ -10690,7 +10690,7 @@
           <a:lstStyle/>
           <a:p>
             <a:fld id="{DBA00916-396A-A444-B6A6-572F44C7530F}" type="datetimeFigureOut">
-              <a:t>2026/7/29</a:t>
+              <a:t>2026/7/30</a:t>
             </a:fld>
             <a:endParaRPr/>
           </a:p>
@@ -11380,7 +11380,7 @@
           <a:lstStyle/>
           <a:p>
             <a:fld id="{DBA00916-396A-A444-B6A6-572F44C7530F}" type="datetimeFigureOut">
-              <a:t>2026/7/29</a:t>
+              <a:t>2026/7/30</a:t>
             </a:fld>
             <a:endParaRPr/>
           </a:p>
@@ -12070,7 +12070,7 @@
           <a:lstStyle/>
           <a:p>
             <a:fld id="{DBA00916-396A-A444-B6A6-572F44C7530F}" type="datetimeFigureOut">
-              <a:t>2026/7/29</a:t>
+              <a:t>2026/7/30</a:t>
             </a:fld>
             <a:endParaRPr/>
           </a:p>
@@ -12783,7 +12783,7 @@
           <a:lstStyle/>
           <a:p>
             <a:fld id="{DBA00916-396A-A444-B6A6-572F44C7530F}" type="datetimeFigureOut">
-              <a:t>2026/7/29</a:t>
+              <a:t>2026/7/30</a:t>
             </a:fld>
             <a:endParaRPr/>
           </a:p>
@@ -13096,7 +13096,7 @@
           <a:lstStyle/>
           <a:p>
             <a:fld id="{DBA00916-396A-A444-B6A6-572F44C7530F}" type="datetimeFigureOut">
-              <a:t>2026/7/29</a:t>
+              <a:t>2026/7/30</a:t>
             </a:fld>
             <a:endParaRPr/>
           </a:p>
@@ -13911,7 +13911,7 @@
           </a:lstStyle>
           <a:p>
             <a:fld id="{DBA00916-396A-A444-B6A6-572F44C7530F}" type="datetimeFigureOut">
-              <a:t>2026/7/29</a:t>
+              <a:t>2026/7/30</a:t>
             </a:fld>
             <a:endParaRPr/>
           </a:p>
@@ -18306,7 +18306,7 @@
               <a:buNone/>
             </a:pPr>
             <a:r>
-              <a:rPr sz="2800" b="1">
+              <a:rPr lang="en-US" sz="2800" b="1">
                 <a:solidFill>
                   <a:srgbClr val="1CA669"/>
                 </a:solidFill>
@@ -18314,8 +18314,16 @@
                 <a:ea typeface="微软雅黑"/>
                 <a:cs typeface="微软雅黑"/>
               </a:rPr>
-              <a:t>133 passed</a:t>
-            </a:r>
+              <a:t>141 passed</a:t>
+            </a:r>
+            <a:endParaRPr sz="2800" b="1">
+              <a:solidFill>
+                <a:srgbClr val="1CA669"/>
+              </a:solidFill>
+              <a:latin typeface="微软雅黑"/>
+              <a:ea typeface="微软雅黑"/>
+              <a:cs typeface="微软雅黑"/>
+            </a:endParaRPr>
           </a:p>
         </p:txBody>
       </p:sp>
@@ -27699,7 +27707,51 @@
                 <a:ea typeface="微软雅黑"/>
                 <a:cs typeface="微软雅黑"/>
               </a:rPr>
-              <a:t>结构化 Action  ·  命令白名单  ·  精确进程匹配  ·  默认 dry-run  ·  Canary 门槛  ·  原子回滚</a:t>
+              <a:t>结构化 Action  ·  命令白名单  ·  精确进程匹配  ·  </a:t>
+            </a:r>
+            <a:r>
+              <a:rPr lang="zh-CN" altLang="en-US" sz="1500">
+                <a:solidFill>
+                  <a:srgbClr val="12192C"/>
+                </a:solidFill>
+                <a:latin typeface="微软雅黑"/>
+                <a:ea typeface="微软雅黑"/>
+                <a:cs typeface="微软雅黑"/>
+              </a:rPr>
+              <a:t>显式 </a:t>
+            </a:r>
+            <a:r>
+              <a:rPr lang="en-US" altLang="zh-CN" sz="1500">
+                <a:solidFill>
+                  <a:srgbClr val="12192C"/>
+                </a:solidFill>
+                <a:latin typeface="微软雅黑"/>
+                <a:ea typeface="微软雅黑"/>
+                <a:cs typeface="微软雅黑"/>
+              </a:rPr>
+              <a:t>--</a:t>
+            </a:r>
+            <a:r>
+              <a:rPr lang="en-US" sz="1500">
+                <a:solidFill>
+                  <a:srgbClr val="12192C"/>
+                </a:solidFill>
+                <a:latin typeface="微软雅黑"/>
+                <a:ea typeface="微软雅黑"/>
+                <a:cs typeface="微软雅黑"/>
+              </a:rPr>
+              <a:t>dry-run</a:t>
+            </a:r>
+            <a:r>
+              <a:rPr sz="1500">
+                <a:solidFill>
+                  <a:srgbClr val="12192C"/>
+                </a:solidFill>
+                <a:latin typeface="微软雅黑"/>
+                <a:ea typeface="微软雅黑"/>
+                <a:cs typeface="微软雅黑"/>
+              </a:rPr>
+              <a:t>  ·  Canary 门槛  ·  原子回滚</a:t>
             </a:r>
           </a:p>
         </p:txBody>
@@ -30608,7 +30660,7 @@
               <a:buNone/>
             </a:pPr>
             <a:r>
-              <a:rPr sz="2800" b="1">
+              <a:rPr lang="en-US" altLang="zh-CN" sz="2800" b="1">
                 <a:solidFill>
                   <a:srgbClr val="2C54E8"/>
                 </a:solidFill>
@@ -30616,7 +30668,18 @@
                 <a:ea typeface="微软雅黑"/>
                 <a:cs typeface="微软雅黑"/>
               </a:rPr>
-              <a:t>12,721 行</a:t>
+              <a:t>13,580</a:t>
+            </a:r>
+            <a:r>
+              <a:rPr sz="2800" b="1">
+                <a:solidFill>
+                  <a:srgbClr val="2C54E8"/>
+                </a:solidFill>
+                <a:latin typeface="微软雅黑"/>
+                <a:ea typeface="微软雅黑"/>
+                <a:cs typeface="微软雅黑"/>
+              </a:rPr>
+              <a:t> 行</a:t>
             </a:r>
           </a:p>
         </p:txBody>
@@ -30760,7 +30823,7 @@
               <a:buNone/>
             </a:pPr>
             <a:r>
-              <a:rPr sz="2800" b="1">
+              <a:rPr lang="en-US" altLang="zh-CN" sz="2800" b="1">
                 <a:solidFill>
                   <a:srgbClr val="6E44EB"/>
                 </a:solidFill>
@@ -30768,7 +30831,18 @@
                 <a:ea typeface="微软雅黑"/>
                 <a:cs typeface="微软雅黑"/>
               </a:rPr>
-              <a:t>1,822 行</a:t>
+              <a:t>2,193</a:t>
+            </a:r>
+            <a:r>
+              <a:rPr sz="2800" b="1">
+                <a:solidFill>
+                  <a:srgbClr val="6E44EB"/>
+                </a:solidFill>
+                <a:latin typeface="微软雅黑"/>
+                <a:ea typeface="微软雅黑"/>
+                <a:cs typeface="微软雅黑"/>
+              </a:rPr>
+              <a:t> 行</a:t>
             </a:r>
           </a:p>
         </p:txBody>
@@ -30912,7 +30986,7 @@
               <a:buNone/>
             </a:pPr>
             <a:r>
-              <a:rPr sz="2800" b="1">
+              <a:rPr lang="en-US" altLang="zh-CN" sz="2800" b="1">
                 <a:solidFill>
                   <a:srgbClr val="15BDE5"/>
                 </a:solidFill>
@@ -30920,7 +30994,18 @@
                 <a:ea typeface="微软雅黑"/>
                 <a:cs typeface="微软雅黑"/>
               </a:rPr>
-              <a:t>14,543 行</a:t>
+              <a:t>15,773</a:t>
+            </a:r>
+            <a:r>
+              <a:rPr sz="2800" b="1">
+                <a:solidFill>
+                  <a:srgbClr val="15BDE5"/>
+                </a:solidFill>
+                <a:latin typeface="微软雅黑"/>
+                <a:ea typeface="微软雅黑"/>
+                <a:cs typeface="微软雅黑"/>
+              </a:rPr>
+              <a:t> 行</a:t>
             </a:r>
           </a:p>
         </p:txBody>
@@ -31354,7 +31439,29 @@
                 <a:ea typeface="微软雅黑"/>
                 <a:cs typeface="微软雅黑"/>
               </a:rPr>
-              <a:t>统计口径：项目随附 code_origin_stats；最终提交前将在干净 Git commit 上重跑。</a:t>
+              <a:t>统计口径：项目随附 </a:t>
+            </a:r>
+            <a:r>
+              <a:rPr lang="en-US" sz="900">
+                <a:solidFill>
+                  <a:srgbClr val="7C89A3"/>
+                </a:solidFill>
+                <a:latin typeface="微软雅黑"/>
+                <a:ea typeface="微软雅黑"/>
+                <a:cs typeface="微软雅黑"/>
+              </a:rPr>
+              <a:t>code_origin_stats.md</a:t>
+            </a:r>
+            <a:r>
+              <a:rPr sz="900">
+                <a:solidFill>
+                  <a:srgbClr val="7C89A3"/>
+                </a:solidFill>
+                <a:latin typeface="微软雅黑"/>
+                <a:ea typeface="微软雅黑"/>
+                <a:cs typeface="微软雅黑"/>
+              </a:rPr>
+              <a:t>；最终提交前将在干净 Git commit 上重跑。</a:t>
             </a:r>
           </a:p>
         </p:txBody>

</xml_diff>